<commit_message>
Slides: check questions at title size and within 10 words (sd-05-002..005)
Co-Authored-By: Claude Opus 5.5 <noreply@anthropic.com>
Claude-Session: https://claude.ai/code/session_01C9pH8NnezrynRr5dznPeP3
</commit_message>
<xml_diff>
--- a/system-design-101/vi/lessons/sd-05-002/slides/sd-05-002.pptx
+++ b/system-design-101/vi/lessons/sd-05-002/slides/sd-05-002.pptx
@@ -15283,192 +15283,82 @@
           <a:ln/>
         </p:spPr>
         <p:txBody>
-          <a:bodyPr wrap="square" lIns="0" tIns="6667" rIns="0" bIns="-6667" rtlCol="0" anchor="t"/>
+          <a:bodyPr wrap="square" lIns="0" tIns="59150" rIns="0" bIns="-59150" rtlCol="0" anchor="t"/>
           <a:lstStyle/>
           <a:p>
             <a:pPr algn="l" indent="0" marL="0">
               <a:lnSpc>
-                <a:spcPts val="4200"/>
+                <a:spcPts val="7245"/>
               </a:lnSpc>
               <a:buNone/>
             </a:pPr>
             <a:r>
-              <a:rPr lang="en-US" sz="3000" dirty="0" spc="-3" kern="0">
+              <a:rPr lang="en-US" sz="6900" dirty="0" spc="4" kern="0">
                 <a:solidFill>
                   <a:srgbClr val="14161C"/>
                 </a:solidFill>
-                <a:latin typeface="Be Vietnam Pro" pitchFamily="34" charset="0"/>
-                <a:ea typeface="Be Vietnam Pro" pitchFamily="34" charset="-122"/>
-                <a:cs typeface="Be Vietnam Pro" pitchFamily="34" charset="-120"/>
+                <a:latin typeface="Bricolage Grotesque ExtraBold" pitchFamily="34" charset="0"/>
+                <a:ea typeface="Bricolage Grotesque ExtraBold" pitchFamily="34" charset="-122"/>
+                <a:cs typeface="Bricolage Grotesque ExtraBold" pitchFamily="34" charset="-120"/>
               </a:rPr>
               <a:t>IP</a:t>
             </a:r>
             <a:r>
-              <a:rPr lang="en-US" sz="3000" dirty="0" spc="1" kern="0">
+              <a:rPr lang="en-US" sz="6900" dirty="0" spc="-1" kern="0">
                 <a:solidFill>
                   <a:srgbClr val="14161C"/>
                 </a:solidFill>
-                <a:latin typeface="Be Vietnam Pro" pitchFamily="34" charset="0"/>
-                <a:ea typeface="Be Vietnam Pro" pitchFamily="34" charset="-122"/>
-                <a:cs typeface="Be Vietnam Pro" pitchFamily="34" charset="-120"/>
-              </a:rPr>
-              <a:t> của</a:t>
-            </a:r>
-            <a:r>
-              <a:rPr lang="en-US" sz="3000" dirty="0" spc="-17" kern="0">
+                <a:latin typeface="Bricolage Grotesque ExtraBold" pitchFamily="34" charset="0"/>
+                <a:ea typeface="Bricolage Grotesque ExtraBold" pitchFamily="34" charset="-122"/>
+                <a:cs typeface="Bricolage Grotesque ExtraBold" pitchFamily="34" charset="-120"/>
+              </a:rPr>
+              <a:t> còn</a:t>
+            </a:r>
+            <a:r>
+              <a:rPr lang="en-US" sz="6900" dirty="0" spc="-13" kern="0">
                 <a:solidFill>
                   <a:srgbClr val="14161C"/>
                 </a:solidFill>
-                <a:latin typeface="Be Vietnam Pro" pitchFamily="34" charset="0"/>
-                <a:ea typeface="Be Vietnam Pro" pitchFamily="34" charset="-122"/>
-                <a:cs typeface="Be Vietnam Pro" pitchFamily="34" charset="-120"/>
-              </a:rPr>
-              <a:t> tên</a:t>
-            </a:r>
-            <a:r>
-              <a:rPr lang="en-US" sz="3000" dirty="0" spc="2" kern="0">
+                <a:latin typeface="Bricolage Grotesque ExtraBold" pitchFamily="34" charset="0"/>
+                <a:ea typeface="Bricolage Grotesque ExtraBold" pitchFamily="34" charset="-122"/>
+                <a:cs typeface="Bricolage Grotesque ExtraBold" pitchFamily="34" charset="-120"/>
+              </a:rPr>
+              <a:t> trong</a:t>
+            </a:r>
+            <a:r>
+              <a:rPr lang="en-US" sz="6900" dirty="0" spc="0" kern="0">
                 <a:solidFill>
                   <a:srgbClr val="14161C"/>
                 </a:solidFill>
-                <a:latin typeface="Be Vietnam Pro" pitchFamily="34" charset="0"/>
-                <a:ea typeface="Be Vietnam Pro" pitchFamily="34" charset="-122"/>
-                <a:cs typeface="Be Vietnam Pro" pitchFamily="34" charset="-120"/>
-              </a:rPr>
-              <a:t> miền</a:t>
-            </a:r>
-            <a:r>
-              <a:rPr lang="en-US" sz="3000" dirty="0" spc="12" kern="0">
+                <a:latin typeface="Bricolage Grotesque ExtraBold" pitchFamily="34" charset="0"/>
+                <a:ea typeface="Bricolage Grotesque ExtraBold" pitchFamily="34" charset="-122"/>
+                <a:cs typeface="Bricolage Grotesque ExtraBold" pitchFamily="34" charset="-120"/>
+              </a:rPr>
+              <a:t> cache: bỏ qua</a:t>
+            </a:r>
+            <a:r>
+              <a:rPr lang="en-US" sz="6900" dirty="0" spc="-95" kern="0">
                 <a:solidFill>
                   <a:srgbClr val="14161C"/>
                 </a:solidFill>
-                <a:latin typeface="Be Vietnam Pro" pitchFamily="34" charset="0"/>
-                <a:ea typeface="Be Vietnam Pro" pitchFamily="34" charset="-122"/>
-                <a:cs typeface="Be Vietnam Pro" pitchFamily="34" charset="-120"/>
-              </a:rPr>
-              <a:t> vừa</a:t>
-            </a:r>
-            <a:r>
-              <a:rPr lang="en-US" sz="3000" dirty="0" spc="-30" kern="0">
+                <a:latin typeface="Bricolage Grotesque ExtraBold" pitchFamily="34" charset="0"/>
+                <a:ea typeface="Bricolage Grotesque ExtraBold" pitchFamily="34" charset="-122"/>
+                <a:cs typeface="Bricolage Grotesque ExtraBold" pitchFamily="34" charset="-120"/>
+              </a:rPr>
+              <a:t> bước</a:t>
+            </a:r>
+            <a:r>
+              <a:rPr lang="en-US" sz="6900" dirty="0" spc="-39" kern="0">
                 <a:solidFill>
                   <a:srgbClr val="14161C"/>
                 </a:solidFill>
-                <a:latin typeface="Be Vietnam Pro" pitchFamily="34" charset="0"/>
-                <a:ea typeface="Be Vietnam Pro" pitchFamily="34" charset="-122"/>
-                <a:cs typeface="Be Vietnam Pro" pitchFamily="34" charset="-120"/>
-              </a:rPr>
-              <a:t> tra</a:t>
-            </a:r>
-            <a:r>
-              <a:rPr lang="en-US" sz="3000" dirty="0" spc="1" kern="0">
-                <a:solidFill>
-                  <a:srgbClr val="14161C"/>
-                </a:solidFill>
-                <a:latin typeface="Be Vietnam Pro" pitchFamily="34" charset="0"/>
-                <a:ea typeface="Be Vietnam Pro" pitchFamily="34" charset="-122"/>
-                <a:cs typeface="Be Vietnam Pro" pitchFamily="34" charset="-120"/>
-              </a:rPr>
-              <a:t> ít</a:t>
-            </a:r>
-            <a:r>
-              <a:rPr lang="en-US" sz="3000" dirty="0" spc="0" kern="0">
-                <a:solidFill>
-                  <a:srgbClr val="14161C"/>
-                </a:solidFill>
-                <a:latin typeface="Be Vietnam Pro" pitchFamily="34" charset="0"/>
-                <a:ea typeface="Be Vietnam Pro" pitchFamily="34" charset="-122"/>
-                <a:cs typeface="Be Vietnam Pro" pitchFamily="34" charset="-120"/>
-              </a:rPr>
-              <a:t> phút</a:t>
-            </a:r>
-            <a:r>
-              <a:rPr lang="en-US" sz="3000" dirty="0" spc="8" kern="0">
-                <a:solidFill>
-                  <a:srgbClr val="14161C"/>
-                </a:solidFill>
-                <a:latin typeface="Be Vietnam Pro" pitchFamily="34" charset="0"/>
-                <a:ea typeface="Be Vietnam Pro" pitchFamily="34" charset="-122"/>
-                <a:cs typeface="Be Vietnam Pro" pitchFamily="34" charset="-120"/>
-              </a:rPr>
-              <a:t> trước,</a:t>
-            </a:r>
-            <a:r>
-              <a:rPr lang="en-US" sz="3000" dirty="0" spc="0" kern="0">
-                <a:solidFill>
-                  <a:srgbClr val="14161C"/>
-                </a:solidFill>
-                <a:latin typeface="Be Vietnam Pro" pitchFamily="34" charset="0"/>
-                <a:ea typeface="Be Vietnam Pro" pitchFamily="34" charset="-122"/>
-                <a:cs typeface="Be Vietnam Pro" pitchFamily="34" charset="-120"/>
-              </a:rPr>
-              <a:t> còn</a:t>
-            </a:r>
-            <a:r>
-              <a:rPr lang="en-US" sz="3000" dirty="0" spc="19" kern="0">
-                <a:solidFill>
-                  <a:srgbClr val="14161C"/>
-                </a:solidFill>
-                <a:latin typeface="Be Vietnam Pro" pitchFamily="34" charset="0"/>
-                <a:ea typeface="Be Vietnam Pro" pitchFamily="34" charset="-122"/>
-                <a:cs typeface="Be Vietnam Pro" pitchFamily="34" charset="-120"/>
-              </a:rPr>
-              <a:t> lưu.</a:t>
-            </a:r>
-            <a:r>
-              <a:rPr lang="en-US" sz="3000" dirty="0" spc="1" kern="0">
-                <a:solidFill>
-                  <a:srgbClr val="14161C"/>
-                </a:solidFill>
-                <a:latin typeface="Be Vietnam Pro" pitchFamily="34" charset="0"/>
-                <a:ea typeface="Be Vietnam Pro" pitchFamily="34" charset="-122"/>
-                <a:cs typeface="Be Vietnam Pro" pitchFamily="34" charset="-120"/>
-              </a:rPr>
-              <a:t> Bỏ</a:t>
-            </a:r>
-            <a:r>
-              <a:rPr lang="en-US" sz="3000" dirty="0" spc="2" kern="0">
-                <a:solidFill>
-                  <a:srgbClr val="14161C"/>
-                </a:solidFill>
-                <a:latin typeface="Be Vietnam Pro" pitchFamily="34" charset="0"/>
-                <a:ea typeface="Be Vietnam Pro" pitchFamily="34" charset="-122"/>
-                <a:cs typeface="Be Vietnam Pro" pitchFamily="34" charset="-120"/>
-              </a:rPr>
-              <a:t> qua</a:t>
-            </a:r>
-            <a:r>
-              <a:rPr lang="en-US" sz="3000" dirty="0" spc="11" kern="0">
-                <a:solidFill>
-                  <a:srgbClr val="14161C"/>
-                </a:solidFill>
-                <a:latin typeface="Be Vietnam Pro" pitchFamily="34" charset="0"/>
-                <a:ea typeface="Be Vietnam Pro" pitchFamily="34" charset="-122"/>
-                <a:cs typeface="Be Vietnam Pro" pitchFamily="34" charset="-120"/>
-              </a:rPr>
-              <a:t> được</a:t>
-            </a:r>
-            <a:r>
-              <a:rPr lang="en-US" sz="3000" dirty="0" spc="13" kern="0">
-                <a:solidFill>
-                  <a:srgbClr val="14161C"/>
-                </a:solidFill>
-                <a:latin typeface="Be Vietnam Pro" pitchFamily="34" charset="0"/>
-                <a:ea typeface="Be Vietnam Pro" pitchFamily="34" charset="-122"/>
-                <a:cs typeface="Be Vietnam Pro" pitchFamily="34" charset="-120"/>
-              </a:rPr>
-              <a:t> bước</a:t>
-            </a:r>
-            <a:r>
-              <a:rPr lang="en-US" sz="3000" dirty="0" spc="-2" kern="0">
-                <a:solidFill>
-                  <a:srgbClr val="14161C"/>
-                </a:solidFill>
-                <a:latin typeface="Be Vietnam Pro" pitchFamily="34" charset="0"/>
-                <a:ea typeface="Be Vietnam Pro" pitchFamily="34" charset="-122"/>
-                <a:cs typeface="Be Vietnam Pro" pitchFamily="34" charset="-120"/>
+                <a:latin typeface="Bricolage Grotesque ExtraBold" pitchFamily="34" charset="0"/>
+                <a:ea typeface="Bricolage Grotesque ExtraBold" pitchFamily="34" charset="-122"/>
+                <a:cs typeface="Bricolage Grotesque ExtraBold" pitchFamily="34" charset="-120"/>
               </a:rPr>
               <a:t> nào?</a:t>
             </a:r>
-            <a:endParaRPr lang="en-US" sz="3000" dirty="0"/>
+            <a:endParaRPr lang="en-US" sz="6900" dirty="0"/>
           </a:p>
         </p:txBody>
       </p:sp>

</xml_diff>